<commit_message>
docs: corrige dos frases de las filminas 4 y 5
Filmina 4: la tarjeta de pruebas decia que el flujo end-to-end cubre
"registro, gasto y alerta". El spec de la #18 hace registro, inicio de
sesion, un ingreso, un gasto y verifica el saldo actualizado; no toca
ninguna alerta. Queda "registro, gasto y saldo actualizado".

Filmina 5: decia "las siete funcionalidades" mientras la filmina 2 dice
ocho. Queda "las ocho funcionalidades".

Las dos las habia señalado @PipeDevGit en la revision del #56.

Refs #21

Co-Authored-By: Claude Opus 5 <noreply@anthropic.com>
</commit_message>
<xml_diff>
--- a/docs/filminas/BudgetWise-5-filminas.pptx
+++ b/docs/filminas/BudgetWise-5-filminas.pptx
@@ -4308,7 +4308,7 @@
                 <a:ea typeface="Calibri" pitchFamily="34" charset="-122"/>
                 <a:cs typeface="Calibri" pitchFamily="34" charset="-120"/>
               </a:rPr>
-              <a:t>JUnit sobre service/ en el backend y Vitest en el frontend: el saldo, las alertas y el progreso de metas se prueban sin levantar Spring. Un flujo end-to-end con Playwright: registro, gasto y alerta.</a:t>
+              <a:t>JUnit sobre service/ en el backend y Vitest en el frontend: el saldo, las alertas y el progreso de metas se prueban sin levantar Spring. Un flujo end-to-end con Playwright: registro, gasto y saldo actualizado.</a:t>
             </a:r>
             <a:endParaRPr lang="en-US" sz="1250" dirty="0"/>
           </a:p>
@@ -4994,7 +4994,7 @@
                 <a:ea typeface="Calibri" pitchFamily="34" charset="-122"/>
                 <a:cs typeface="Calibri" pitchFamily="34" charset="-120"/>
               </a:rPr>
-              <a:t>Un recorrido de punta a punta por las siete funcionalidades.</a:t>
+              <a:t>Un recorrido de punta a punta por las ocho funcionalidades.</a:t>
             </a:r>
             <a:endParaRPr lang="en-US" sz="1400" dirty="0"/>
           </a:p>

</xml_diff>

<commit_message>
docs: cifras de la filmina 5, aceptacion del PO y retro de Pablo
Filmina 5: las tres cifras estaban en blanco a proposito, para no poner
numeros inventados. Ahora salen de main al 16 de septiembre: 19 de 20
historias del backlog, 145 pruebas (95 backend, 49 frontend, 1 E2E) y
14 de 15 criterios de la rubrica. Las notas del orador dejan de pedir la
captura del E2E, que ya esta en el repositorio desde el #61.

sprint-2-review.md: la tabla de aceptacion del Product Owner, con lo que
se verifico en cada historia y no solo un "si".

sprint-2-retrospectiva.md: lo que le tocaba escribir a Pablo.

Refs #21
Refs #85

Co-Authored-By: Claude Opus 5 <noreply@anthropic.com>
</commit_message>
<xml_diff>
--- a/docs/filminas/BudgetWise-5-filminas.pptx
+++ b/docs/filminas/BudgetWise-5-filminas.pptx
@@ -858,7 +858,7 @@
           <a:p>
             <a:r>
               <a:rPr lang="en-US" dirty="0"/>
-              <a:t>GUION — 3 minutos 30, de los cuales 2:30 son la demo en vivo. Habla Pablo. Primero las cifras, 30 segundos. Despues la demo, siguiendo los seis pasos en orden y sin improvisar. Tener la aplicacion levantada y con sesion iniciada ANTES de empezar: no se arranca docker compose delante del profesor. Plan B si la demo falla: mostrar la captura de la corrida E2E (issue #18). ESTA FILMINA SIGUE INCOMPLETA: las tres cifras se llenan al cerrar el Sprint 3, con datos reales. No presentar numeros inventados. Falta pedirle a Felipe la captura de la #18 antes del 22.</a:t>
+              <a:t>GUION — 3 minutos 30, de los cuales 2:30 son la demo en vivo. Habla Pablo. Primero las cifras, 30 segundos. Despues la demo, siguiendo los seis pasos en orden y sin improvisar. Tener la aplicacion levantada y con sesion iniciada ANTES de empezar: no se arranca docker compose delante del profesor. Plan B si la demo falla: mostrar la captura de la corrida E2E, que ya esta en el repositorio: docs/scrum/capturas/e2e-flujo-principal.png. Las tres cifras estan medidas sobre main el 16 de septiembre, no estimadas: 19 de 20 historias del backlog (la unica abierta es esta presentacion), 145 pruebas (95 de backend, 49 de frontend y 1 end-to-end) y 14 de 15 criterios de la rubrica; el que falta es la exposicion, que se evalua ese mismo dia. Si entra algun PR con pruebas nuevas antes del 23, actualizar el numero.</a:t>
             </a:r>
             <a:endParaRPr lang="en-US" dirty="0"/>
           </a:p>
@@ -5822,7 +5822,7 @@
                 <a:ea typeface="Calibri" pitchFamily="34" charset="-122"/>
                 <a:cs typeface="Calibri" pitchFamily="34" charset="-120"/>
               </a:rPr>
-              <a:t>—</a:t>
+              <a:t>19 de 20</a:t>
             </a:r>
             <a:endParaRPr lang="en-US" sz="1800" dirty="0"/>
           </a:p>
@@ -5954,7 +5954,7 @@
                 <a:ea typeface="Calibri" pitchFamily="34" charset="-122"/>
                 <a:cs typeface="Calibri" pitchFamily="34" charset="-120"/>
               </a:rPr>
-              <a:t>—</a:t>
+              <a:t>145</a:t>
             </a:r>
             <a:endParaRPr lang="en-US" sz="1800" dirty="0"/>
           </a:p>
@@ -6086,7 +6086,7 @@
                 <a:ea typeface="Calibri" pitchFamily="34" charset="-122"/>
                 <a:cs typeface="Calibri" pitchFamily="34" charset="-120"/>
               </a:rPr>
-              <a:t>—</a:t>
+              <a:t>14 de 15</a:t>
             </a:r>
             <a:endParaRPr lang="en-US" sz="1800" dirty="0"/>
           </a:p>
@@ -6128,7 +6128,7 @@
                 <a:ea typeface="Calibri" pitchFamily="34" charset="-122"/>
                 <a:cs typeface="Calibri" pitchFamily="34" charset="-120"/>
               </a:rPr>
-              <a:t>Pendiente al cierre del Sprint 3: completar las tres cifras y agregar la captura de la corrida E2E (issue #18).</a:t>
+              <a:t>Medido sobre main el 16 de septiembre: 95 pruebas de backend, 49 de frontend y 1 end-to-end.</a:t>
             </a:r>
             <a:endParaRPr lang="en-US" sz="1100" dirty="0"/>
           </a:p>

</xml_diff>